<commit_message>
Update slides outline and PPTX with GitHub repository and live website URLs
</commit_message>
<xml_diff>
--- a/Final_Project_Presentation_Final.pptx
+++ b/Final_Project_Presentation_Final.pptx
@@ -4558,7 +4558,7 @@
                 <a:ea typeface="微軟正黑體"/>
                 <a:cs typeface="Cambria"/>
               </a:rPr>
-              <a:t>ICU Mortality Prediction &amp; Physiological Time-Series Analysis</a:t>
+              <a:t>ICU Mortality Prediction &amp; Time-Series Analysis | GitHub: waynelee9511cloud/advanced-icu-mpla</a:t>
             </a:r>
             <a:endParaRPr lang="en-US" altLang="zh-CN" sz="2400" b="1" dirty="0">
               <a:solidFill>
@@ -8490,6 +8490,26 @@
                 <a:cs typeface="Cambria"/>
               </a:rPr>
               <a:t>**Risk Simulator**: Grouped 5x2 physiological sliders with side-by-side gauge predictions and clinical recommendations, updating in real-time on a single page</a:t>
+            </a:r>
+          </a:p>
+          <a:p>
+            <a:pPr marL="514350" indent="-457200" algn="l">
+              <a:defRPr>
+                <a:latin typeface="Cambria"/>
+                <a:ea typeface="微軟正黑體"/>
+                <a:cs typeface="Cambria"/>
+              </a:defRPr>
+            </a:pPr>
+            <a:r>
+              <a:rPr sz="1800">
+                <a:solidFill>
+                  <a:schemeClr val="tx1"/>
+                </a:solidFill>
+                <a:latin typeface="Cambria"/>
+                <a:ea typeface="微軟正黑體"/>
+                <a:cs typeface="Cambria"/>
+              </a:rPr>
+              <a:t>**Live URL**: [advanced-icu-mpla.streamlit.app](https://advanced-icu-mpla.streamlit.app) (Free Streamlit Cloud Hosting)</a:t>
             </a:r>
           </a:p>
         </p:txBody>
@@ -9916,6 +9936,66 @@
                 <a:cs typeface="Cambria"/>
               </a:rPr>
               <a:t>Validate model generalizability using external databases (e.g., MIMIC-IV) and multi-center cohorts</a:t>
+            </a:r>
+          </a:p>
+          <a:p>
+            <a:pPr marL="514350" indent="-457200" algn="l">
+              <a:defRPr>
+                <a:latin typeface="Cambria"/>
+                <a:ea typeface="微軟正黑體"/>
+                <a:cs typeface="Cambria"/>
+              </a:defRPr>
+            </a:pPr>
+            <a:r>
+              <a:rPr sz="1800">
+                <a:solidFill>
+                  <a:schemeClr val="tx1"/>
+                </a:solidFill>
+                <a:latin typeface="Cambria"/>
+                <a:ea typeface="微軟正黑體"/>
+                <a:cs typeface="Cambria"/>
+              </a:rPr>
+              <a:t>**Project Resources**:</a:t>
+            </a:r>
+          </a:p>
+          <a:p>
+            <a:pPr lvl="1" marL="1023938" indent="-623888" algn="l">
+              <a:defRPr>
+                <a:latin typeface="Cambria"/>
+                <a:ea typeface="微軟正黑體"/>
+                <a:cs typeface="Cambria"/>
+              </a:defRPr>
+            </a:pPr>
+            <a:r>
+              <a:rPr sz="1800">
+                <a:solidFill>
+                  <a:schemeClr val="tx1"/>
+                </a:solidFill>
+                <a:latin typeface="Cambria"/>
+                <a:ea typeface="微軟正黑體"/>
+                <a:cs typeface="Cambria"/>
+              </a:rPr>
+              <a:t>**GitHub Codebase**: [github.com/waynelee9511cloud/advanced-icu-mpla](https://github.com/waynelee9511cloud/advanced-icu-mpla)</a:t>
+            </a:r>
+          </a:p>
+          <a:p>
+            <a:pPr lvl="1" marL="1023938" indent="-623888" algn="l">
+              <a:defRPr>
+                <a:latin typeface="Cambria"/>
+                <a:ea typeface="微軟正黑體"/>
+                <a:cs typeface="Cambria"/>
+              </a:defRPr>
+            </a:pPr>
+            <a:r>
+              <a:rPr sz="1800">
+                <a:solidFill>
+                  <a:schemeClr val="tx1"/>
+                </a:solidFill>
+                <a:latin typeface="Cambria"/>
+                <a:ea typeface="微軟正黑體"/>
+                <a:cs typeface="Cambria"/>
+              </a:rPr>
+              <a:t>**Live Dashboard Application**: [advanced-icu-mpla.streamlit.app](https://advanced-icu-mpla.streamlit.app)</a:t>
             </a:r>
           </a:p>
         </p:txBody>

</xml_diff>